<commit_message>
documentacion actualizada: descripcion del despliegue
</commit_message>
<xml_diff>
--- a/doc/memoria_proyecto/Memoria_Proyecto.pptx
+++ b/doc/memoria_proyecto/Memoria_Proyecto.pptx
@@ -219,7 +219,7 @@
           <a:p>
             <a:fld id="{44C7761D-94E6-4E59-97F6-B29C25850D68}" type="datetimeFigureOut">
               <a:rPr lang="es-ES" smtClean="0"/>
-              <a:t>11/07/2026</a:t>
+              <a:t>12/07/2026</a:t>
             </a:fld>
             <a:endParaRPr lang="es-ES"/>
           </a:p>
@@ -1049,7 +1049,7 @@
           <a:p>
             <a:fld id="{5BCAD085-E8A6-8845-BD4E-CB4CCA059FC4}" type="datetimeFigureOut">
               <a:rPr lang="en-US" smtClean="0"/>
-              <a:t>7/11/2026</a:t>
+              <a:t>7/12/2026</a:t>
             </a:fld>
             <a:endParaRPr lang="en-US"/>
           </a:p>
@@ -1217,7 +1217,7 @@
           <a:p>
             <a:fld id="{5BCAD085-E8A6-8845-BD4E-CB4CCA059FC4}" type="datetimeFigureOut">
               <a:rPr lang="en-US" smtClean="0"/>
-              <a:t>7/11/2026</a:t>
+              <a:t>7/12/2026</a:t>
             </a:fld>
             <a:endParaRPr lang="en-US"/>
           </a:p>
@@ -1395,7 +1395,7 @@
           <a:p>
             <a:fld id="{5BCAD085-E8A6-8845-BD4E-CB4CCA059FC4}" type="datetimeFigureOut">
               <a:rPr lang="en-US" smtClean="0"/>
-              <a:t>7/11/2026</a:t>
+              <a:t>7/12/2026</a:t>
             </a:fld>
             <a:endParaRPr lang="en-US"/>
           </a:p>
@@ -1563,7 +1563,7 @@
           <a:p>
             <a:fld id="{5BCAD085-E8A6-8845-BD4E-CB4CCA059FC4}" type="datetimeFigureOut">
               <a:rPr lang="en-US" smtClean="0"/>
-              <a:t>7/11/2026</a:t>
+              <a:t>7/12/2026</a:t>
             </a:fld>
             <a:endParaRPr lang="en-US"/>
           </a:p>
@@ -1808,7 +1808,7 @@
           <a:p>
             <a:fld id="{5BCAD085-E8A6-8845-BD4E-CB4CCA059FC4}" type="datetimeFigureOut">
               <a:rPr lang="en-US" smtClean="0"/>
-              <a:t>7/11/2026</a:t>
+              <a:t>7/12/2026</a:t>
             </a:fld>
             <a:endParaRPr lang="en-US"/>
           </a:p>
@@ -2093,7 +2093,7 @@
           <a:p>
             <a:fld id="{5BCAD085-E8A6-8845-BD4E-CB4CCA059FC4}" type="datetimeFigureOut">
               <a:rPr lang="en-US" smtClean="0"/>
-              <a:t>7/11/2026</a:t>
+              <a:t>7/12/2026</a:t>
             </a:fld>
             <a:endParaRPr lang="en-US"/>
           </a:p>
@@ -2512,7 +2512,7 @@
           <a:p>
             <a:fld id="{5BCAD085-E8A6-8845-BD4E-CB4CCA059FC4}" type="datetimeFigureOut">
               <a:rPr lang="en-US" smtClean="0"/>
-              <a:t>7/11/2026</a:t>
+              <a:t>7/12/2026</a:t>
             </a:fld>
             <a:endParaRPr lang="en-US"/>
           </a:p>
@@ -2629,7 +2629,7 @@
           <a:p>
             <a:fld id="{5BCAD085-E8A6-8845-BD4E-CB4CCA059FC4}" type="datetimeFigureOut">
               <a:rPr lang="en-US" smtClean="0"/>
-              <a:t>7/11/2026</a:t>
+              <a:t>7/12/2026</a:t>
             </a:fld>
             <a:endParaRPr lang="en-US"/>
           </a:p>
@@ -2724,7 +2724,7 @@
           <a:p>
             <a:fld id="{5BCAD085-E8A6-8845-BD4E-CB4CCA059FC4}" type="datetimeFigureOut">
               <a:rPr lang="en-US" smtClean="0"/>
-              <a:t>7/11/2026</a:t>
+              <a:t>7/12/2026</a:t>
             </a:fld>
             <a:endParaRPr lang="en-US"/>
           </a:p>
@@ -2999,7 +2999,7 @@
           <a:p>
             <a:fld id="{5BCAD085-E8A6-8845-BD4E-CB4CCA059FC4}" type="datetimeFigureOut">
               <a:rPr lang="en-US" smtClean="0"/>
-              <a:t>7/11/2026</a:t>
+              <a:t>7/12/2026</a:t>
             </a:fld>
             <a:endParaRPr lang="en-US"/>
           </a:p>
@@ -3251,7 +3251,7 @@
           <a:p>
             <a:fld id="{5BCAD085-E8A6-8845-BD4E-CB4CCA059FC4}" type="datetimeFigureOut">
               <a:rPr lang="en-US" smtClean="0"/>
-              <a:t>7/11/2026</a:t>
+              <a:t>7/12/2026</a:t>
             </a:fld>
             <a:endParaRPr lang="en-US"/>
           </a:p>
@@ -3462,7 +3462,7 @@
           <a:p>
             <a:fld id="{5BCAD085-E8A6-8845-BD4E-CB4CCA059FC4}" type="datetimeFigureOut">
               <a:rPr lang="en-US" smtClean="0"/>
-              <a:t>7/11/2026</a:t>
+              <a:t>7/12/2026</a:t>
             </a:fld>
             <a:endParaRPr lang="en-US"/>
           </a:p>
@@ -19045,13 +19045,13 @@
           <p:nvPr>
             <p:extLst>
               <p:ext uri="{D42A27DB-BD31-4B8C-83A1-F6EECF244321}">
-                <p14:modId xmlns:p14="http://schemas.microsoft.com/office/powerpoint/2010/main" val="3874749225"/>
+                <p14:modId xmlns:p14="http://schemas.microsoft.com/office/powerpoint/2010/main" val="3921054368"/>
               </p:ext>
             </p:extLst>
           </p:nvPr>
         </p:nvGraphicFramePr>
         <p:xfrm>
-          <a:off x="457200" y="1234440"/>
+          <a:off x="457200" y="1170428"/>
           <a:ext cx="5577840" cy="1097280"/>
         </p:xfrm>
         <a:graphic>
@@ -19539,8 +19539,8 @@
         </p:nvSpPr>
         <p:spPr>
           <a:xfrm>
-            <a:off x="6400800" y="1234440"/>
-            <a:ext cx="5303520" cy="1828800"/>
+            <a:off x="6400800" y="1147424"/>
+            <a:ext cx="5303520" cy="2442497"/>
           </a:xfrm>
           <a:prstGeom prst="rect">
             <a:avLst/>
@@ -19578,75 +19578,12 @@
           <a:lstStyle/>
           <a:p>
             <a:pPr algn="ctr"/>
-            <a:r>
-              <a:rPr sz="1200">
-                <a:solidFill>
-                  <a:srgbClr val="D6E2F0"/>
-                </a:solidFill>
-                <a:latin typeface="Consolas"/>
-              </a:rPr>
-              <a:t>        Internet</a:t>
-            </a:r>
-          </a:p>
-          <a:p>
-            <a:pPr algn="ctr"/>
-            <a:r>
-              <a:rPr sz="1200">
-                <a:solidFill>
-                  <a:srgbClr val="D6E2F0"/>
-                </a:solidFill>
-                <a:latin typeface="Consolas"/>
-              </a:rPr>
-              <a:t>           |</a:t>
-            </a:r>
-          </a:p>
-          <a:p>
-            <a:pPr algn="ctr"/>
-            <a:r>
-              <a:rPr sz="1200">
-                <a:solidFill>
-                  <a:srgbClr val="D6E2F0"/>
-                </a:solidFill>
-                <a:latin typeface="Consolas"/>
-              </a:rPr>
-              <a:t>   nginx (reverse proxy) + UI</a:t>
-            </a:r>
-          </a:p>
-          <a:p>
-            <a:pPr algn="ctr"/>
-            <a:r>
-              <a:rPr sz="1200">
-                <a:solidFill>
-                  <a:srgbClr val="D6E2F0"/>
-                </a:solidFill>
-                <a:latin typeface="Consolas"/>
-              </a:rPr>
-              <a:t>           |  enruta hacia</a:t>
-            </a:r>
-          </a:p>
-          <a:p>
-            <a:pPr algn="ctr"/>
-            <a:r>
-              <a:rPr sz="1200">
-                <a:solidFill>
-                  <a:srgbClr val="D6E2F0"/>
-                </a:solidFill>
-                <a:latin typeface="Consolas"/>
-              </a:rPr>
-              <a:t>  +----+----+----+----+----+</a:t>
-            </a:r>
-          </a:p>
-          <a:p>
-            <a:pPr algn="ctr"/>
-            <a:r>
-              <a:rPr sz="1200">
-                <a:solidFill>
-                  <a:srgbClr val="D6E2F0"/>
-                </a:solidFill>
-                <a:latin typeface="Consolas"/>
-              </a:rPr>
-              <a:t> BFF Keycloak Postgres S3 Worker</a:t>
-            </a:r>
+            <a:endParaRPr sz="1200" dirty="0">
+              <a:solidFill>
+                <a:srgbClr val="D6E2F0"/>
+              </a:solidFill>
+              <a:latin typeface="Consolas"/>
+            </a:endParaRPr>
           </a:p>
         </p:txBody>
       </p:sp>
@@ -19658,8 +19595,8 @@
         </p:nvSpPr>
         <p:spPr>
           <a:xfrm>
-            <a:off x="457200" y="3246121"/>
-            <a:ext cx="11247120" cy="3509521"/>
+            <a:off x="457200" y="3698467"/>
+            <a:ext cx="11247120" cy="3056295"/>
           </a:xfrm>
           <a:prstGeom prst="roundRect">
             <a:avLst/>
@@ -19863,7 +19800,25 @@
                 </a:solidFill>
                 <a:latin typeface="Aptos Light" panose="020B0004020202020204" pitchFamily="34" charset="0"/>
               </a:rPr>
-              <a:t> un </a:t>
+              <a:t> un nginx</a:t>
+            </a:r>
+            <a:r>
+              <a:rPr lang="es-ES" sz="1600" dirty="0">
+                <a:solidFill>
+                  <a:srgbClr val="444A54"/>
+                </a:solidFill>
+                <a:latin typeface="Aptos Light" panose="020B0004020202020204" pitchFamily="34" charset="0"/>
+              </a:rPr>
+              <a:t> y una red privada</a:t>
+            </a:r>
+            <a:r>
+              <a:rPr sz="1600" dirty="0">
+                <a:solidFill>
+                  <a:srgbClr val="444A54"/>
+                </a:solidFill>
+                <a:latin typeface="Aptos Light" panose="020B0004020202020204" pitchFamily="34" charset="0"/>
+              </a:rPr>
+              <a:t>, </a:t>
             </a:r>
             <a:r>
               <a:rPr sz="1600" dirty="0" err="1">
@@ -19872,7 +19827,7 @@
                 </a:solidFill>
                 <a:latin typeface="Aptos Light" panose="020B0004020202020204" pitchFamily="34" charset="0"/>
               </a:rPr>
-              <a:t>mismo</a:t>
+              <a:t>en</a:t>
             </a:r>
             <a:r>
               <a:rPr sz="1600" dirty="0">
@@ -19881,7 +19836,16 @@
                 </a:solidFill>
                 <a:latin typeface="Aptos Light" panose="020B0004020202020204" pitchFamily="34" charset="0"/>
               </a:rPr>
-              <a:t> nginx, </a:t>
+              <a:t> </a:t>
+            </a:r>
+            <a:r>
+              <a:rPr lang="es-ES" sz="1600" dirty="0">
+                <a:solidFill>
+                  <a:srgbClr val="444A54"/>
+                </a:solidFill>
+                <a:latin typeface="Aptos Light" panose="020B0004020202020204" pitchFamily="34" charset="0"/>
+              </a:rPr>
+              <a:t>DOS </a:t>
             </a:r>
             <a:r>
               <a:rPr sz="1600" dirty="0" err="1">
@@ -19890,25 +19854,16 @@
                 </a:solidFill>
                 <a:latin typeface="Aptos Light" panose="020B0004020202020204" pitchFamily="34" charset="0"/>
               </a:rPr>
-              <a:t>en</a:t>
-            </a:r>
-            <a:r>
-              <a:rPr sz="1600" dirty="0">
-                <a:solidFill>
-                  <a:srgbClr val="444A54"/>
-                </a:solidFill>
-                <a:latin typeface="Aptos Light" panose="020B0004020202020204" pitchFamily="34" charset="0"/>
-              </a:rPr>
-              <a:t> UN </a:t>
-            </a:r>
-            <a:r>
-              <a:rPr sz="1600" dirty="0" err="1">
-                <a:solidFill>
-                  <a:srgbClr val="444A54"/>
-                </a:solidFill>
-                <a:latin typeface="Aptos Light" panose="020B0004020202020204" pitchFamily="34" charset="0"/>
-              </a:rPr>
               <a:t>nodo</a:t>
+            </a:r>
+            <a:r>
+              <a:rPr lang="es-ES" sz="1600" dirty="0">
+                <a:solidFill>
+                  <a:srgbClr val="444A54"/>
+                </a:solidFill>
+                <a:latin typeface="Aptos Light" panose="020B0004020202020204" pitchFamily="34" charset="0"/>
+              </a:rPr>
+              <a:t>s</a:t>
             </a:r>
             <a:r>
               <a:rPr sz="1600" dirty="0">
@@ -20393,7 +20348,43 @@
                 </a:solidFill>
                 <a:latin typeface="Aptos Light" panose="020B0004020202020204" pitchFamily="34" charset="0"/>
               </a:rPr>
-              <a:t>l nginx es hoy un </a:t>
+              <a:t>l nginx</a:t>
+            </a:r>
+            <a:r>
+              <a:rPr lang="es-ES" sz="1600" dirty="0">
+                <a:solidFill>
+                  <a:srgbClr val="444A54"/>
+                </a:solidFill>
+                <a:latin typeface="Aptos Light" panose="020B0004020202020204" pitchFamily="34" charset="0"/>
+              </a:rPr>
+              <a:t> y el host son</a:t>
+            </a:r>
+            <a:r>
+              <a:rPr sz="1600" dirty="0">
+                <a:solidFill>
+                  <a:srgbClr val="444A54"/>
+                </a:solidFill>
+                <a:latin typeface="Aptos Light" panose="020B0004020202020204" pitchFamily="34" charset="0"/>
+              </a:rPr>
+              <a:t> </a:t>
+            </a:r>
+            <a:r>
+              <a:rPr lang="es-ES" sz="1600" dirty="0">
+                <a:solidFill>
+                  <a:srgbClr val="444A54"/>
+                </a:solidFill>
+                <a:latin typeface="Aptos Light" panose="020B0004020202020204" pitchFamily="34" charset="0"/>
+              </a:rPr>
+              <a:t>h</a:t>
+            </a:r>
+            <a:r>
+              <a:rPr sz="1600" dirty="0">
+                <a:solidFill>
+                  <a:srgbClr val="444A54"/>
+                </a:solidFill>
+                <a:latin typeface="Aptos Light" panose="020B0004020202020204" pitchFamily="34" charset="0"/>
+              </a:rPr>
+              <a:t>oy </a:t>
             </a:r>
             <a:r>
               <a:rPr lang="es-ES" sz="1600" b="1" dirty="0">
@@ -20404,7 +20395,7 @@
                 </a:solidFill>
                 <a:latin typeface="Aptos Light" panose="020B0004020202020204" pitchFamily="34" charset="0"/>
               </a:rPr>
-              <a:t>único punto de fallo</a:t>
+              <a:t>únicos puntos de fallo</a:t>
             </a:r>
             <a:r>
               <a:rPr sz="1600" dirty="0">
@@ -20413,7 +20404,16 @@
                 </a:solidFill>
                 <a:latin typeface="Aptos Light" panose="020B0004020202020204" pitchFamily="34" charset="0"/>
               </a:rPr>
-              <a:t>. Pasar de un </a:t>
+              <a:t>. Pasar de </a:t>
+            </a:r>
+            <a:r>
+              <a:rPr lang="es-ES" sz="1600" dirty="0">
+                <a:solidFill>
+                  <a:srgbClr val="444A54"/>
+                </a:solidFill>
+                <a:latin typeface="Aptos Light" panose="020B0004020202020204" pitchFamily="34" charset="0"/>
+              </a:rPr>
+              <a:t>de </a:t>
             </a:r>
             <a:r>
               <a:rPr sz="1600" dirty="0" err="1">
@@ -20423,6 +20423,15 @@
                 <a:latin typeface="Aptos Light" panose="020B0004020202020204" pitchFamily="34" charset="0"/>
               </a:rPr>
               <a:t>nodo</a:t>
+            </a:r>
+            <a:r>
+              <a:rPr lang="es-ES" sz="1600" dirty="0">
+                <a:solidFill>
+                  <a:srgbClr val="444A54"/>
+                </a:solidFill>
+                <a:latin typeface="Aptos Light" panose="020B0004020202020204" pitchFamily="34" charset="0"/>
+              </a:rPr>
+              <a:t>s</a:t>
             </a:r>
             <a:r>
               <a:rPr sz="1600" dirty="0">
@@ -20508,6 +20517,36 @@
           </a:p>
         </p:txBody>
       </p:sp>
+      <p:pic>
+        <p:nvPicPr>
+          <p:cNvPr id="9" name="Imagen 8">
+            <a:extLst>
+              <a:ext uri="{FF2B5EF4-FFF2-40B4-BE49-F238E27FC236}">
+                <a16:creationId xmlns:a16="http://schemas.microsoft.com/office/drawing/2014/main" id="{765D2E68-75C2-ECDB-806B-AD3FBACB6656}"/>
+              </a:ext>
+            </a:extLst>
+          </p:cNvPr>
+          <p:cNvPicPr>
+            <a:picLocks noChangeAspect="1"/>
+          </p:cNvPicPr>
+          <p:nvPr/>
+        </p:nvPicPr>
+        <p:blipFill>
+          <a:blip r:embed="rId3"/>
+          <a:stretch>
+            <a:fillRect/>
+          </a:stretch>
+        </p:blipFill>
+        <p:spPr>
+          <a:xfrm>
+            <a:off x="7848139" y="1234440"/>
+            <a:ext cx="2744153" cy="2259617"/>
+          </a:xfrm>
+          <a:prstGeom prst="rect">
+            <a:avLst/>
+          </a:prstGeom>
+        </p:spPr>
+      </p:pic>
     </p:spTree>
   </p:cSld>
   <p:clrMapOvr>

</xml_diff>

<commit_message>
Añadir cambios en presentacion y actualizacion de bbdd en Runbook
</commit_message>
<xml_diff>
--- a/doc/memoria_proyecto/Memoria_Proyecto.pptx
+++ b/doc/memoria_proyecto/Memoria_Proyecto.pptx
@@ -5,7 +5,7 @@
     <p:sldMasterId id="2147483648" r:id="rId1"/>
   </p:sldMasterIdLst>
   <p:notesMasterIdLst>
-    <p:notesMasterId r:id="rId16"/>
+    <p:notesMasterId r:id="rId17"/>
   </p:notesMasterIdLst>
   <p:sldIdLst>
     <p:sldId id="256" r:id="rId2"/>
@@ -22,6 +22,7 @@
     <p:sldId id="264" r:id="rId13"/>
     <p:sldId id="265" r:id="rId14"/>
     <p:sldId id="269" r:id="rId15"/>
+    <p:sldId id="270" r:id="rId16"/>
   </p:sldIdLst>
   <p:sldSz cx="12192000" cy="6858000"/>
   <p:notesSz cx="6858000" cy="9144000"/>
@@ -221,7 +222,7 @@
           <a:p>
             <a:fld id="{44C7761D-94E6-4E59-97F6-B29C25850D68}" type="datetimeFigureOut">
               <a:rPr lang="es-ES" smtClean="0"/>
-              <a:t>16/07/2026</a:t>
+              <a:t>18/07/2026</a:t>
             </a:fld>
             <a:endParaRPr lang="es-ES"/>
           </a:p>
@@ -1051,7 +1052,7 @@
           <a:p>
             <a:fld id="{5BCAD085-E8A6-8845-BD4E-CB4CCA059FC4}" type="datetimeFigureOut">
               <a:rPr lang="en-US" smtClean="0"/>
-              <a:t>7/16/2026</a:t>
+              <a:t>7/18/2026</a:t>
             </a:fld>
             <a:endParaRPr lang="en-US"/>
           </a:p>
@@ -1219,7 +1220,7 @@
           <a:p>
             <a:fld id="{5BCAD085-E8A6-8845-BD4E-CB4CCA059FC4}" type="datetimeFigureOut">
               <a:rPr lang="en-US" smtClean="0"/>
-              <a:t>7/16/2026</a:t>
+              <a:t>7/18/2026</a:t>
             </a:fld>
             <a:endParaRPr lang="en-US"/>
           </a:p>
@@ -1397,7 +1398,7 @@
           <a:p>
             <a:fld id="{5BCAD085-E8A6-8845-BD4E-CB4CCA059FC4}" type="datetimeFigureOut">
               <a:rPr lang="en-US" smtClean="0"/>
-              <a:t>7/16/2026</a:t>
+              <a:t>7/18/2026</a:t>
             </a:fld>
             <a:endParaRPr lang="en-US"/>
           </a:p>
@@ -1565,7 +1566,7 @@
           <a:p>
             <a:fld id="{5BCAD085-E8A6-8845-BD4E-CB4CCA059FC4}" type="datetimeFigureOut">
               <a:rPr lang="en-US" smtClean="0"/>
-              <a:t>7/16/2026</a:t>
+              <a:t>7/18/2026</a:t>
             </a:fld>
             <a:endParaRPr lang="en-US"/>
           </a:p>
@@ -1810,7 +1811,7 @@
           <a:p>
             <a:fld id="{5BCAD085-E8A6-8845-BD4E-CB4CCA059FC4}" type="datetimeFigureOut">
               <a:rPr lang="en-US" smtClean="0"/>
-              <a:t>7/16/2026</a:t>
+              <a:t>7/18/2026</a:t>
             </a:fld>
             <a:endParaRPr lang="en-US"/>
           </a:p>
@@ -2095,7 +2096,7 @@
           <a:p>
             <a:fld id="{5BCAD085-E8A6-8845-BD4E-CB4CCA059FC4}" type="datetimeFigureOut">
               <a:rPr lang="en-US" smtClean="0"/>
-              <a:t>7/16/2026</a:t>
+              <a:t>7/18/2026</a:t>
             </a:fld>
             <a:endParaRPr lang="en-US"/>
           </a:p>
@@ -2514,7 +2515,7 @@
           <a:p>
             <a:fld id="{5BCAD085-E8A6-8845-BD4E-CB4CCA059FC4}" type="datetimeFigureOut">
               <a:rPr lang="en-US" smtClean="0"/>
-              <a:t>7/16/2026</a:t>
+              <a:t>7/18/2026</a:t>
             </a:fld>
             <a:endParaRPr lang="en-US"/>
           </a:p>
@@ -2631,7 +2632,7 @@
           <a:p>
             <a:fld id="{5BCAD085-E8A6-8845-BD4E-CB4CCA059FC4}" type="datetimeFigureOut">
               <a:rPr lang="en-US" smtClean="0"/>
-              <a:t>7/16/2026</a:t>
+              <a:t>7/18/2026</a:t>
             </a:fld>
             <a:endParaRPr lang="en-US"/>
           </a:p>
@@ -2726,7 +2727,7 @@
           <a:p>
             <a:fld id="{5BCAD085-E8A6-8845-BD4E-CB4CCA059FC4}" type="datetimeFigureOut">
               <a:rPr lang="en-US" smtClean="0"/>
-              <a:t>7/16/2026</a:t>
+              <a:t>7/18/2026</a:t>
             </a:fld>
             <a:endParaRPr lang="en-US"/>
           </a:p>
@@ -3001,7 +3002,7 @@
           <a:p>
             <a:fld id="{5BCAD085-E8A6-8845-BD4E-CB4CCA059FC4}" type="datetimeFigureOut">
               <a:rPr lang="en-US" smtClean="0"/>
-              <a:t>7/16/2026</a:t>
+              <a:t>7/18/2026</a:t>
             </a:fld>
             <a:endParaRPr lang="en-US"/>
           </a:p>
@@ -3253,7 +3254,7 @@
           <a:p>
             <a:fld id="{5BCAD085-E8A6-8845-BD4E-CB4CCA059FC4}" type="datetimeFigureOut">
               <a:rPr lang="en-US" smtClean="0"/>
-              <a:t>7/16/2026</a:t>
+              <a:t>7/18/2026</a:t>
             </a:fld>
             <a:endParaRPr lang="en-US"/>
           </a:p>
@@ -3464,7 +3465,7 @@
           <a:p>
             <a:fld id="{5BCAD085-E8A6-8845-BD4E-CB4CCA059FC4}" type="datetimeFigureOut">
               <a:rPr lang="en-US" smtClean="0"/>
-              <a:t>7/16/2026</a:t>
+              <a:t>7/18/2026</a:t>
             </a:fld>
             <a:endParaRPr lang="en-US"/>
           </a:p>
@@ -4043,7 +4044,7 @@
                 </a:solidFill>
                 <a:latin typeface="Aptos"/>
               </a:rPr>
-              <a:t>Julio 2026 – Jose A Pelaez Calderon</a:t>
+              <a:t>Julio 2026 – Jose A Pelaez</a:t>
             </a:r>
             <a:endParaRPr sz="1400" b="0" dirty="0">
               <a:solidFill>
@@ -12997,6 +12998,346 @@
     <p:extLst>
       <p:ext uri="{BB962C8B-B14F-4D97-AF65-F5344CB8AC3E}">
         <p14:creationId xmlns:p14="http://schemas.microsoft.com/office/powerpoint/2010/main" val="409472612"/>
+      </p:ext>
+    </p:extLst>
+  </p:cSld>
+  <p:clrMapOvr>
+    <a:masterClrMapping/>
+  </p:clrMapOvr>
+</p:sld>
+</file>
+
+<file path=ppt/slides/slide15.xml><?xml version="1.0" encoding="utf-8"?>
+<p:sld xmlns:a="http://schemas.openxmlformats.org/drawingml/2006/main" xmlns:r="http://schemas.openxmlformats.org/officeDocument/2006/relationships" xmlns:p="http://schemas.openxmlformats.org/presentationml/2006/main">
+  <p:cSld>
+    <p:spTree>
+      <p:nvGrpSpPr>
+        <p:cNvPr id="1" name="">
+          <a:extLst>
+            <a:ext uri="{FF2B5EF4-FFF2-40B4-BE49-F238E27FC236}">
+              <a16:creationId xmlns:a16="http://schemas.microsoft.com/office/drawing/2014/main" id="{D5471D48-6190-D278-E872-1FE8D896AA11}"/>
+            </a:ext>
+          </a:extLst>
+        </p:cNvPr>
+        <p:cNvGrpSpPr/>
+        <p:nvPr/>
+      </p:nvGrpSpPr>
+      <p:grpSpPr>
+        <a:xfrm>
+          <a:off x="0" y="0"/>
+          <a:ext cx="0" cy="0"/>
+          <a:chOff x="0" y="0"/>
+          <a:chExt cx="0" cy="0"/>
+        </a:xfrm>
+      </p:grpSpPr>
+      <p:sp>
+        <p:nvSpPr>
+          <p:cNvPr id="2" name="Rectangle 1">
+            <a:extLst>
+              <a:ext uri="{FF2B5EF4-FFF2-40B4-BE49-F238E27FC236}">
+                <a16:creationId xmlns:a16="http://schemas.microsoft.com/office/drawing/2014/main" id="{763C6703-FA45-555B-9944-F05E230BF63A}"/>
+              </a:ext>
+            </a:extLst>
+          </p:cNvPr>
+          <p:cNvSpPr/>
+          <p:nvPr/>
+        </p:nvSpPr>
+        <p:spPr>
+          <a:xfrm>
+            <a:off x="0" y="5120640"/>
+            <a:ext cx="12191695" cy="1737360"/>
+          </a:xfrm>
+          <a:prstGeom prst="rect">
+            <a:avLst/>
+          </a:prstGeom>
+          <a:solidFill>
+            <a:srgbClr val="0E8A7E"/>
+          </a:solidFill>
+          <a:ln>
+            <a:noFill/>
+          </a:ln>
+          <a:effectLst/>
+        </p:spPr>
+        <p:style>
+          <a:lnRef idx="1">
+            <a:schemeClr val="accent1"/>
+          </a:lnRef>
+          <a:fillRef idx="3">
+            <a:schemeClr val="accent1"/>
+          </a:fillRef>
+          <a:effectRef idx="2">
+            <a:schemeClr val="accent1"/>
+          </a:effectRef>
+          <a:fontRef idx="minor">
+            <a:schemeClr val="lt1"/>
+          </a:fontRef>
+        </p:style>
+        <p:txBody>
+          <a:bodyPr rtlCol="0" anchor="ctr"/>
+          <a:lstStyle/>
+          <a:p>
+            <a:pPr algn="ctr"/>
+            <a:endParaRPr/>
+          </a:p>
+        </p:txBody>
+      </p:sp>
+      <p:sp>
+        <p:nvSpPr>
+          <p:cNvPr id="3" name="TextBox 2">
+            <a:extLst>
+              <a:ext uri="{FF2B5EF4-FFF2-40B4-BE49-F238E27FC236}">
+                <a16:creationId xmlns:a16="http://schemas.microsoft.com/office/drawing/2014/main" id="{31D4CC62-6182-DB91-7BBE-5C28FFFA571D}"/>
+              </a:ext>
+            </a:extLst>
+          </p:cNvPr>
+          <p:cNvSpPr txBox="1"/>
+          <p:nvPr/>
+        </p:nvSpPr>
+        <p:spPr>
+          <a:xfrm>
+            <a:off x="2032328" y="1352639"/>
+            <a:ext cx="10515600" cy="769441"/>
+          </a:xfrm>
+          <a:prstGeom prst="rect">
+            <a:avLst/>
+          </a:prstGeom>
+          <a:noFill/>
+        </p:spPr>
+        <p:txBody>
+          <a:bodyPr wrap="square" anchor="t">
+            <a:spAutoFit/>
+          </a:bodyPr>
+          <a:lstStyle/>
+          <a:p>
+            <a:pPr algn="l">
+              <a:spcAft>
+                <a:spcPts val="600"/>
+              </a:spcAft>
+            </a:pPr>
+            <a:r>
+              <a:rPr lang="es-ES" sz="4400" b="1" dirty="0">
+                <a:latin typeface="Aptos"/>
+              </a:rPr>
+              <a:t>GRACIAS POR LA ATENCION</a:t>
+            </a:r>
+            <a:endParaRPr sz="4400" b="1" dirty="0">
+              <a:latin typeface="Aptos"/>
+            </a:endParaRPr>
+          </a:p>
+        </p:txBody>
+      </p:sp>
+      <p:sp>
+        <p:nvSpPr>
+          <p:cNvPr id="4" name="TextBox 3">
+            <a:extLst>
+              <a:ext uri="{FF2B5EF4-FFF2-40B4-BE49-F238E27FC236}">
+                <a16:creationId xmlns:a16="http://schemas.microsoft.com/office/drawing/2014/main" id="{8F268D50-E4D0-0102-C9B1-A4B3B4DE5AB6}"/>
+              </a:ext>
+            </a:extLst>
+          </p:cNvPr>
+          <p:cNvSpPr txBox="1"/>
+          <p:nvPr/>
+        </p:nvSpPr>
+        <p:spPr>
+          <a:xfrm>
+            <a:off x="361798" y="5389155"/>
+            <a:ext cx="10058400" cy="1200329"/>
+          </a:xfrm>
+          <a:prstGeom prst="rect">
+            <a:avLst/>
+          </a:prstGeom>
+          <a:noFill/>
+        </p:spPr>
+        <p:txBody>
+          <a:bodyPr wrap="square" anchor="t">
+            <a:spAutoFit/>
+          </a:bodyPr>
+          <a:lstStyle/>
+          <a:p>
+            <a:pPr algn="l">
+              <a:spcAft>
+                <a:spcPts val="600"/>
+              </a:spcAft>
+            </a:pPr>
+            <a:r>
+              <a:rPr lang="es-ES" sz="2400" dirty="0">
+                <a:solidFill>
+                  <a:srgbClr val="B9CFE8"/>
+                </a:solidFill>
+                <a:latin typeface="Aptos"/>
+              </a:rPr>
+              <a:t>Master de Desarrollo con IA – Big School</a:t>
+            </a:r>
+          </a:p>
+          <a:p>
+            <a:pPr algn="l">
+              <a:spcAft>
+                <a:spcPts val="600"/>
+              </a:spcAft>
+            </a:pPr>
+            <a:r>
+              <a:rPr lang="es-ES" sz="2400" b="0" dirty="0">
+                <a:solidFill>
+                  <a:srgbClr val="B9CFE8"/>
+                </a:solidFill>
+                <a:latin typeface="Aptos"/>
+              </a:rPr>
+              <a:t>Memoria del Proyecto Final de Master</a:t>
+            </a:r>
+          </a:p>
+          <a:p>
+            <a:pPr algn="l">
+              <a:spcAft>
+                <a:spcPts val="600"/>
+              </a:spcAft>
+            </a:pPr>
+            <a:r>
+              <a:rPr lang="es-ES" sz="1400" dirty="0">
+                <a:solidFill>
+                  <a:srgbClr val="B9CFE8"/>
+                </a:solidFill>
+                <a:latin typeface="Aptos"/>
+              </a:rPr>
+              <a:t>Julio 2026 – Jose A Pelaez</a:t>
+            </a:r>
+            <a:endParaRPr sz="1400" b="0" dirty="0">
+              <a:solidFill>
+                <a:srgbClr val="B9CFE8"/>
+              </a:solidFill>
+              <a:latin typeface="Aptos"/>
+            </a:endParaRPr>
+          </a:p>
+        </p:txBody>
+      </p:sp>
+      <p:sp>
+        <p:nvSpPr>
+          <p:cNvPr id="6" name="TextBox 3">
+            <a:extLst>
+              <a:ext uri="{FF2B5EF4-FFF2-40B4-BE49-F238E27FC236}">
+                <a16:creationId xmlns:a16="http://schemas.microsoft.com/office/drawing/2014/main" id="{755976B6-1A7B-153F-F89E-A847BE37311B}"/>
+              </a:ext>
+            </a:extLst>
+          </p:cNvPr>
+          <p:cNvSpPr txBox="1"/>
+          <p:nvPr/>
+        </p:nvSpPr>
+        <p:spPr>
+          <a:xfrm>
+            <a:off x="361798" y="3058536"/>
+            <a:ext cx="10058400" cy="2062103"/>
+          </a:xfrm>
+          <a:prstGeom prst="rect">
+            <a:avLst/>
+          </a:prstGeom>
+          <a:noFill/>
+        </p:spPr>
+        <p:txBody>
+          <a:bodyPr wrap="square" anchor="t">
+            <a:spAutoFit/>
+          </a:bodyPr>
+          <a:lstStyle/>
+          <a:p>
+            <a:pPr algn="l">
+              <a:spcAft>
+                <a:spcPts val="600"/>
+              </a:spcAft>
+            </a:pPr>
+            <a:r>
+              <a:rPr lang="es-ES" b="0" dirty="0">
+                <a:latin typeface="Aptos"/>
+              </a:rPr>
+              <a:t>Agradecimientos:</a:t>
+            </a:r>
+            <a:br>
+              <a:rPr lang="es-ES" b="0" dirty="0">
+                <a:latin typeface="Aptos"/>
+              </a:rPr>
+            </a:br>
+            <a:endParaRPr lang="es-ES" b="0" dirty="0">
+              <a:latin typeface="Aptos"/>
+            </a:endParaRPr>
+          </a:p>
+          <a:p>
+            <a:pPr algn="l">
+              <a:spcAft>
+                <a:spcPts val="600"/>
+              </a:spcAft>
+            </a:pPr>
+            <a:r>
+              <a:rPr lang="es-ES" dirty="0">
+                <a:latin typeface="Aptos"/>
+              </a:rPr>
+              <a:t>Francisco Pelaez (Paciente)</a:t>
+            </a:r>
+          </a:p>
+          <a:p>
+            <a:pPr>
+              <a:spcAft>
+                <a:spcPts val="600"/>
+              </a:spcAft>
+            </a:pPr>
+            <a:r>
+              <a:rPr lang="es-ES" dirty="0">
+                <a:latin typeface="Aptos"/>
+              </a:rPr>
+              <a:t>Remedios Calderon (Terapeuta)</a:t>
+            </a:r>
+          </a:p>
+          <a:p>
+            <a:pPr>
+              <a:spcAft>
+                <a:spcPts val="600"/>
+              </a:spcAft>
+            </a:pPr>
+            <a:r>
+              <a:rPr lang="es-ES" dirty="0">
+                <a:latin typeface="Aptos"/>
+              </a:rPr>
+              <a:t>Ana </a:t>
+            </a:r>
+            <a:r>
+              <a:rPr lang="es-ES" dirty="0" err="1">
+                <a:latin typeface="Aptos"/>
+              </a:rPr>
+              <a:t>Mª</a:t>
+            </a:r>
+            <a:r>
+              <a:rPr lang="es-ES" dirty="0">
+                <a:latin typeface="Aptos"/>
+              </a:rPr>
+              <a:t> </a:t>
+            </a:r>
+            <a:r>
+              <a:rPr lang="es-ES" dirty="0" err="1">
+                <a:latin typeface="Aptos"/>
+              </a:rPr>
+              <a:t>Lopez</a:t>
+            </a:r>
+            <a:r>
+              <a:rPr lang="es-ES" dirty="0">
+                <a:latin typeface="Aptos"/>
+              </a:rPr>
+              <a:t> (Idea original)</a:t>
+            </a:r>
+          </a:p>
+          <a:p>
+            <a:pPr marL="285750" indent="-285750">
+              <a:spcAft>
+                <a:spcPts val="600"/>
+              </a:spcAft>
+              <a:buFont typeface="Arial" panose="020B0604020202020204" pitchFamily="34" charset="0"/>
+              <a:buChar char="•"/>
+            </a:pPr>
+            <a:endParaRPr lang="es-ES" b="0" dirty="0">
+              <a:latin typeface="Aptos"/>
+            </a:endParaRPr>
+          </a:p>
+        </p:txBody>
+      </p:sp>
+    </p:spTree>
+    <p:extLst>
+      <p:ext uri="{BB962C8B-B14F-4D97-AF65-F5344CB8AC3E}">
+        <p14:creationId xmlns:p14="http://schemas.microsoft.com/office/powerpoint/2010/main" val="3806256655"/>
       </p:ext>
     </p:extLst>
   </p:cSld>

</xml_diff>

<commit_message>
Añadir consentimiento firmado en presentacion + Auditioria de Infrastructura desplegada + script de control de estado de Infra
</commit_message>
<xml_diff>
--- a/doc/memoria_proyecto/Memoria_Proyecto.pptx
+++ b/doc/memoria_proyecto/Memoria_Proyecto.pptx
@@ -10552,14 +10552,14 @@
           <p:nvPr>
             <p:extLst>
               <p:ext uri="{D42A27DB-BD31-4B8C-83A1-F6EECF244321}">
-                <p14:modId xmlns:p14="http://schemas.microsoft.com/office/powerpoint/2010/main" val="612535443"/>
+                <p14:modId xmlns:p14="http://schemas.microsoft.com/office/powerpoint/2010/main" val="2820240101"/>
               </p:ext>
             </p:extLst>
           </p:nvPr>
         </p:nvGraphicFramePr>
         <p:xfrm>
           <a:off x="472287" y="2256656"/>
-          <a:ext cx="11247120" cy="2468880"/>
+          <a:ext cx="11247120" cy="2834640"/>
         </p:xfrm>
         <a:graphic>
           <a:graphicData uri="http://schemas.openxmlformats.org/drawingml/2006/table">
@@ -11241,6 +11241,15 @@
                       <a:headEnd type="none" w="med" len="med"/>
                       <a:tailEnd type="none" w="med" len="med"/>
                     </a:lnT>
+                    <a:lnB w="12700" cap="flat" cmpd="sng" algn="ctr">
+                      <a:solidFill>
+                        <a:schemeClr val="tx1"/>
+                      </a:solidFill>
+                      <a:prstDash val="solid"/>
+                      <a:round/>
+                      <a:headEnd type="none" w="med" len="med"/>
+                      <a:tailEnd type="none" w="med" len="med"/>
+                    </a:lnB>
                     <a:solidFill>
                       <a:schemeClr val="bg1"/>
                     </a:solidFill>
@@ -11471,6 +11480,15 @@
                       <a:headEnd type="none" w="med" len="med"/>
                       <a:tailEnd type="none" w="med" len="med"/>
                     </a:lnT>
+                    <a:lnB w="12700" cap="flat" cmpd="sng" algn="ctr">
+                      <a:solidFill>
+                        <a:schemeClr val="tx1"/>
+                      </a:solidFill>
+                      <a:prstDash val="solid"/>
+                      <a:round/>
+                      <a:headEnd type="none" w="med" len="med"/>
+                      <a:tailEnd type="none" w="med" len="med"/>
+                    </a:lnB>
                     <a:solidFill>
                       <a:schemeClr val="bg1"/>
                     </a:solidFill>
@@ -11479,6 +11497,126 @@
                 <a:extLst>
                   <a:ext uri="{0D108BD9-81ED-4DB2-BD59-A6C34878D82A}">
                     <a16:rowId xmlns:a16="http://schemas.microsoft.com/office/drawing/2014/main" val="10004"/>
+                  </a:ext>
+                </a:extLst>
+              </a:tr>
+              <a:tr h="365760">
+                <a:tc>
+                  <a:txBody>
+                    <a:bodyPr/>
+                    <a:lstStyle/>
+                    <a:p>
+                      <a:pPr marL="0" algn="ctr" defTabSz="457200" rtl="0" eaLnBrk="1" latinLnBrk="0" hangingPunct="1"/>
+                      <a:r>
+                        <a:rPr lang="es-ES" sz="1600" b="0" kern="1200" dirty="0">
+                          <a:solidFill>
+                            <a:schemeClr val="tx1"/>
+                          </a:solidFill>
+                          <a:latin typeface="Aptos Light" panose="020B0004020202020204" pitchFamily="34" charset="0"/>
+                          <a:ea typeface="+mn-ea"/>
+                          <a:cs typeface="+mn-cs"/>
+                        </a:rPr>
+                        <a:t>Consentimiento firmado</a:t>
+                      </a:r>
+                      <a:endParaRPr sz="1600" b="0" kern="1200" dirty="0">
+                        <a:solidFill>
+                          <a:schemeClr val="tx1"/>
+                        </a:solidFill>
+                        <a:latin typeface="Aptos Light" panose="020B0004020202020204" pitchFamily="34" charset="0"/>
+                        <a:ea typeface="+mn-ea"/>
+                        <a:cs typeface="+mn-cs"/>
+                      </a:endParaRPr>
+                    </a:p>
+                  </a:txBody>
+                  <a:tcPr>
+                    <a:lnR w="12700" cap="flat" cmpd="sng" algn="ctr">
+                      <a:solidFill>
+                        <a:schemeClr val="tx1"/>
+                      </a:solidFill>
+                      <a:prstDash val="solid"/>
+                      <a:round/>
+                      <a:headEnd type="none" w="med" len="med"/>
+                      <a:tailEnd type="none" w="med" len="med"/>
+                    </a:lnR>
+                    <a:lnT w="12700" cap="flat" cmpd="sng" algn="ctr">
+                      <a:solidFill>
+                        <a:schemeClr val="tx1"/>
+                      </a:solidFill>
+                      <a:prstDash val="solid"/>
+                      <a:round/>
+                      <a:headEnd type="none" w="med" len="med"/>
+                      <a:tailEnd type="none" w="med" len="med"/>
+                    </a:lnT>
+                    <a:solidFill>
+                      <a:schemeClr val="bg1"/>
+                    </a:solidFill>
+                  </a:tcPr>
+                </a:tc>
+                <a:tc>
+                  <a:txBody>
+                    <a:bodyPr/>
+                    <a:lstStyle/>
+                    <a:p>
+                      <a:pPr marL="0" algn="ctr" defTabSz="457200" rtl="0" eaLnBrk="1" latinLnBrk="0" hangingPunct="1"/>
+                      <a:r>
+                        <a:rPr lang="es-ES" sz="1600" b="0" kern="1200" dirty="0">
+                          <a:solidFill>
+                            <a:schemeClr val="tx1"/>
+                          </a:solidFill>
+                          <a:latin typeface="Aptos Light" panose="020B0004020202020204" pitchFamily="34" charset="0"/>
+                          <a:ea typeface="+mn-ea"/>
+                          <a:cs typeface="+mn-cs"/>
+                        </a:rPr>
+                        <a:t>Consentimiento registrado, no firmado con </a:t>
+                      </a:r>
+                      <a:r>
+                        <a:rPr lang="es-ES" sz="1600" b="0" kern="1200">
+                          <a:solidFill>
+                            <a:schemeClr val="tx1"/>
+                          </a:solidFill>
+                          <a:latin typeface="Aptos Light" panose="020B0004020202020204" pitchFamily="34" charset="0"/>
+                          <a:ea typeface="+mn-ea"/>
+                          <a:cs typeface="+mn-cs"/>
+                        </a:rPr>
+                        <a:t>firma digital (CERES,…)</a:t>
+                      </a:r>
+                      <a:endParaRPr sz="1600" b="0" kern="1200" dirty="0">
+                        <a:solidFill>
+                          <a:schemeClr val="tx1"/>
+                        </a:solidFill>
+                        <a:latin typeface="Aptos Light" panose="020B0004020202020204" pitchFamily="34" charset="0"/>
+                        <a:ea typeface="+mn-ea"/>
+                        <a:cs typeface="+mn-cs"/>
+                      </a:endParaRPr>
+                    </a:p>
+                  </a:txBody>
+                  <a:tcPr>
+                    <a:lnL w="12700" cap="flat" cmpd="sng" algn="ctr">
+                      <a:solidFill>
+                        <a:schemeClr val="tx1"/>
+                      </a:solidFill>
+                      <a:prstDash val="solid"/>
+                      <a:round/>
+                      <a:headEnd type="none" w="med" len="med"/>
+                      <a:tailEnd type="none" w="med" len="med"/>
+                    </a:lnL>
+                    <a:lnT w="12700" cap="flat" cmpd="sng" algn="ctr">
+                      <a:solidFill>
+                        <a:schemeClr val="tx1"/>
+                      </a:solidFill>
+                      <a:prstDash val="solid"/>
+                      <a:round/>
+                      <a:headEnd type="none" w="med" len="med"/>
+                      <a:tailEnd type="none" w="med" len="med"/>
+                    </a:lnT>
+                    <a:solidFill>
+                      <a:schemeClr val="bg1"/>
+                    </a:solidFill>
+                  </a:tcPr>
+                </a:tc>
+                <a:extLst>
+                  <a:ext uri="{0D108BD9-81ED-4DB2-BD59-A6C34878D82A}">
+                    <a16:rowId xmlns:a16="http://schemas.microsoft.com/office/drawing/2014/main" val="2851869677"/>
                   </a:ext>
                 </a:extLst>
               </a:tr>
@@ -11494,7 +11632,7 @@
         </p:nvSpPr>
         <p:spPr>
           <a:xfrm>
-            <a:off x="457200" y="5126974"/>
+            <a:off x="457200" y="5333446"/>
             <a:ext cx="11247120" cy="1416564"/>
           </a:xfrm>
           <a:prstGeom prst="roundRect">

</xml_diff>

<commit_message>
añadida la nota de auditoria de infrastructura en ppt
</commit_message>
<xml_diff>
--- a/doc/memoria_proyecto/Memoria_Proyecto.pptx
+++ b/doc/memoria_proyecto/Memoria_Proyecto.pptx
@@ -222,7 +222,7 @@
           <a:p>
             <a:fld id="{44C7761D-94E6-4E59-97F6-B29C25850D68}" type="datetimeFigureOut">
               <a:rPr lang="es-ES" smtClean="0"/>
-              <a:t>18/07/2026</a:t>
+              <a:t>19/07/2026</a:t>
             </a:fld>
             <a:endParaRPr lang="es-ES"/>
           </a:p>
@@ -1052,7 +1052,7 @@
           <a:p>
             <a:fld id="{5BCAD085-E8A6-8845-BD4E-CB4CCA059FC4}" type="datetimeFigureOut">
               <a:rPr lang="en-US" smtClean="0"/>
-              <a:t>7/18/2026</a:t>
+              <a:t>7/19/2026</a:t>
             </a:fld>
             <a:endParaRPr lang="en-US"/>
           </a:p>
@@ -1220,7 +1220,7 @@
           <a:p>
             <a:fld id="{5BCAD085-E8A6-8845-BD4E-CB4CCA059FC4}" type="datetimeFigureOut">
               <a:rPr lang="en-US" smtClean="0"/>
-              <a:t>7/18/2026</a:t>
+              <a:t>7/19/2026</a:t>
             </a:fld>
             <a:endParaRPr lang="en-US"/>
           </a:p>
@@ -1398,7 +1398,7 @@
           <a:p>
             <a:fld id="{5BCAD085-E8A6-8845-BD4E-CB4CCA059FC4}" type="datetimeFigureOut">
               <a:rPr lang="en-US" smtClean="0"/>
-              <a:t>7/18/2026</a:t>
+              <a:t>7/19/2026</a:t>
             </a:fld>
             <a:endParaRPr lang="en-US"/>
           </a:p>
@@ -1566,7 +1566,7 @@
           <a:p>
             <a:fld id="{5BCAD085-E8A6-8845-BD4E-CB4CCA059FC4}" type="datetimeFigureOut">
               <a:rPr lang="en-US" smtClean="0"/>
-              <a:t>7/18/2026</a:t>
+              <a:t>7/19/2026</a:t>
             </a:fld>
             <a:endParaRPr lang="en-US"/>
           </a:p>
@@ -1811,7 +1811,7 @@
           <a:p>
             <a:fld id="{5BCAD085-E8A6-8845-BD4E-CB4CCA059FC4}" type="datetimeFigureOut">
               <a:rPr lang="en-US" smtClean="0"/>
-              <a:t>7/18/2026</a:t>
+              <a:t>7/19/2026</a:t>
             </a:fld>
             <a:endParaRPr lang="en-US"/>
           </a:p>
@@ -2096,7 +2096,7 @@
           <a:p>
             <a:fld id="{5BCAD085-E8A6-8845-BD4E-CB4CCA059FC4}" type="datetimeFigureOut">
               <a:rPr lang="en-US" smtClean="0"/>
-              <a:t>7/18/2026</a:t>
+              <a:t>7/19/2026</a:t>
             </a:fld>
             <a:endParaRPr lang="en-US"/>
           </a:p>
@@ -2515,7 +2515,7 @@
           <a:p>
             <a:fld id="{5BCAD085-E8A6-8845-BD4E-CB4CCA059FC4}" type="datetimeFigureOut">
               <a:rPr lang="en-US" smtClean="0"/>
-              <a:t>7/18/2026</a:t>
+              <a:t>7/19/2026</a:t>
             </a:fld>
             <a:endParaRPr lang="en-US"/>
           </a:p>
@@ -2632,7 +2632,7 @@
           <a:p>
             <a:fld id="{5BCAD085-E8A6-8845-BD4E-CB4CCA059FC4}" type="datetimeFigureOut">
               <a:rPr lang="en-US" smtClean="0"/>
-              <a:t>7/18/2026</a:t>
+              <a:t>7/19/2026</a:t>
             </a:fld>
             <a:endParaRPr lang="en-US"/>
           </a:p>
@@ -2727,7 +2727,7 @@
           <a:p>
             <a:fld id="{5BCAD085-E8A6-8845-BD4E-CB4CCA059FC4}" type="datetimeFigureOut">
               <a:rPr lang="en-US" smtClean="0"/>
-              <a:t>7/18/2026</a:t>
+              <a:t>7/19/2026</a:t>
             </a:fld>
             <a:endParaRPr lang="en-US"/>
           </a:p>
@@ -3002,7 +3002,7 @@
           <a:p>
             <a:fld id="{5BCAD085-E8A6-8845-BD4E-CB4CCA059FC4}" type="datetimeFigureOut">
               <a:rPr lang="en-US" smtClean="0"/>
-              <a:t>7/18/2026</a:t>
+              <a:t>7/19/2026</a:t>
             </a:fld>
             <a:endParaRPr lang="en-US"/>
           </a:p>
@@ -3254,7 +3254,7 @@
           <a:p>
             <a:fld id="{5BCAD085-E8A6-8845-BD4E-CB4CCA059FC4}" type="datetimeFigureOut">
               <a:rPr lang="en-US" smtClean="0"/>
-              <a:t>7/18/2026</a:t>
+              <a:t>7/19/2026</a:t>
             </a:fld>
             <a:endParaRPr lang="en-US"/>
           </a:p>
@@ -3465,7 +3465,7 @@
           <a:p>
             <a:fld id="{5BCAD085-E8A6-8845-BD4E-CB4CCA059FC4}" type="datetimeFigureOut">
               <a:rPr lang="en-US" smtClean="0"/>
-              <a:t>7/18/2026</a:t>
+              <a:t>7/19/2026</a:t>
             </a:fld>
             <a:endParaRPr lang="en-US"/>
           </a:p>
@@ -4894,7 +4894,7 @@
                 </a:solidFill>
                 <a:latin typeface="Aptos Light"/>
               </a:rPr>
-              <a:t>Auditoria: se han realizado 2 auditorias de código cubriendo OWASP-10 y aspectos de arquitectura</a:t>
+              <a:t>Auditoria: se han realizado 2 auditorias de código (+1 de infraestructura) cubriendo OWASP-10 y aspectos de arquitectura</a:t>
             </a:r>
             <a:endParaRPr sz="1600" dirty="0">
               <a:solidFill>

</xml_diff>

<commit_message>
Añadir URL a las slides de codigo
</commit_message>
<xml_diff>
--- a/doc/memoria_proyecto/Memoria_Proyecto.pptx
+++ b/doc/memoria_proyecto/Memoria_Proyecto.pptx
@@ -13662,7 +13662,7 @@
         <p:spPr>
           <a:xfrm>
             <a:off x="548640" y="1371600"/>
-            <a:ext cx="11064240" cy="2200602"/>
+            <a:ext cx="11064240" cy="2523768"/>
           </a:xfrm>
           <a:prstGeom prst="rect">
             <a:avLst/>
@@ -13674,6 +13674,28 @@
             <a:spAutoFit/>
           </a:bodyPr>
           <a:lstStyle/>
+          <a:p>
+            <a:pPr algn="ctr">
+              <a:spcAft>
+                <a:spcPts val="600"/>
+              </a:spcAft>
+            </a:pPr>
+            <a:r>
+              <a:rPr lang="es-ES" sz="1600">
+                <a:solidFill>
+                  <a:srgbClr val="444A54"/>
+                </a:solidFill>
+                <a:latin typeface="Aptos Light"/>
+              </a:rPr>
+              <a:t>https://ftm-followup-checkup.duckdns.org/</a:t>
+            </a:r>
+            <a:endParaRPr lang="es-ES" sz="1600" dirty="0">
+              <a:solidFill>
+                <a:srgbClr val="444A54"/>
+              </a:solidFill>
+              <a:latin typeface="Aptos Light"/>
+            </a:endParaRPr>
+          </a:p>
           <a:p>
             <a:pPr algn="just">
               <a:spcAft>

</xml_diff>